<commit_message>
Polish TransitAI prototype deliverables
</commit_message>
<xml_diff>
--- a/TransitAI_UTM_Prototype_Demo.pptx
+++ b/TransitAI_UTM_Prototype_Demo.pptx
@@ -2,22 +2,22 @@
 <file path=ppt/presentation.xml><?xml version="1.0" encoding="utf-8"?>
 <p:presentation xmlns:p="http://schemas.openxmlformats.org/presentationml/2006/main">
   <p:sldMasterIdLst>
-    <p:sldMasterId xmlns:r="http://schemas.openxmlformats.org/officeDocument/2006/relationships" id="2147483648" r:id="Rfba60ba8b1eb4e7d"/>
+    <p:sldMasterId xmlns:r="http://schemas.openxmlformats.org/officeDocument/2006/relationships" id="2147483648" r:id="Re6968b920d2b4f18"/>
   </p:sldMasterIdLst>
   <p:notesMasterIdLst>
-    <p:notesMasterId xmlns:r="http://schemas.openxmlformats.org/officeDocument/2006/relationships" r:id="Rcd5ff5c737b3435a"/>
+    <p:notesMasterId xmlns:r="http://schemas.openxmlformats.org/officeDocument/2006/relationships" r:id="R3f3668ae672d4a1e"/>
   </p:notesMasterIdLst>
   <p:sldIdLst>
-    <p:sldId xmlns:r="http://schemas.openxmlformats.org/officeDocument/2006/relationships" id="256" r:id="R5ca943f2ca684dd2"/>
-    <p:sldId xmlns:r="http://schemas.openxmlformats.org/officeDocument/2006/relationships" id="257" r:id="R1d1f71743dd34333"/>
-    <p:sldId xmlns:r="http://schemas.openxmlformats.org/officeDocument/2006/relationships" id="258" r:id="Rf1cd323786564c5c"/>
-    <p:sldId xmlns:r="http://schemas.openxmlformats.org/officeDocument/2006/relationships" id="259" r:id="Rabb850589ff54f84"/>
-    <p:sldId xmlns:r="http://schemas.openxmlformats.org/officeDocument/2006/relationships" id="260" r:id="Re6984e7aec764368"/>
-    <p:sldId xmlns:r="http://schemas.openxmlformats.org/officeDocument/2006/relationships" id="261" r:id="Rdd929d77e23f4f84"/>
-    <p:sldId xmlns:r="http://schemas.openxmlformats.org/officeDocument/2006/relationships" id="262" r:id="Rc092ab0851fd4521"/>
-    <p:sldId xmlns:r="http://schemas.openxmlformats.org/officeDocument/2006/relationships" id="263" r:id="R5adc8ab293cc45c1"/>
-    <p:sldId xmlns:r="http://schemas.openxmlformats.org/officeDocument/2006/relationships" id="264" r:id="Rdf58a9fe132a45a0"/>
-    <p:sldId xmlns:r="http://schemas.openxmlformats.org/officeDocument/2006/relationships" id="265" r:id="R2ccd83415770486d"/>
+    <p:sldId xmlns:r="http://schemas.openxmlformats.org/officeDocument/2006/relationships" id="256" r:id="Rcd7d7fc6a9ba4296"/>
+    <p:sldId xmlns:r="http://schemas.openxmlformats.org/officeDocument/2006/relationships" id="257" r:id="Ra9b761b65f9745fa"/>
+    <p:sldId xmlns:r="http://schemas.openxmlformats.org/officeDocument/2006/relationships" id="258" r:id="Rfd79b0ac69124a85"/>
+    <p:sldId xmlns:r="http://schemas.openxmlformats.org/officeDocument/2006/relationships" id="259" r:id="Rdccca3af663546cb"/>
+    <p:sldId xmlns:r="http://schemas.openxmlformats.org/officeDocument/2006/relationships" id="260" r:id="Rde8f8372e0974bc0"/>
+    <p:sldId xmlns:r="http://schemas.openxmlformats.org/officeDocument/2006/relationships" id="261" r:id="R93aa76229ced4490"/>
+    <p:sldId xmlns:r="http://schemas.openxmlformats.org/officeDocument/2006/relationships" id="262" r:id="Rb3aa93acec774bd8"/>
+    <p:sldId xmlns:r="http://schemas.openxmlformats.org/officeDocument/2006/relationships" id="263" r:id="Rf818cf3428184a84"/>
+    <p:sldId xmlns:r="http://schemas.openxmlformats.org/officeDocument/2006/relationships" id="264" r:id="Rf7173f7027134b04"/>
+    <p:sldId xmlns:r="http://schemas.openxmlformats.org/officeDocument/2006/relationships" id="265" r:id="Ra46844c380274326"/>
   </p:sldIdLst>
   <p:sldSz cx="12192000" cy="6858000"/>
   <p:notesSz cx="6858000" cy="9144000"/>
@@ -261,7 +261,7 @@
 </p:notesMaster>
 </file>
 
-<file path=ppt/notesMasters/theme/theme2.xml><?xml version="1.0" encoding="utf-8"?>
+<file path=ppt/notesMasters/theme/theme3.xml><?xml version="1.0" encoding="utf-8"?>
 <a:theme xmlns:a="http://schemas.openxmlformats.org/drawingml/2006/main" name="ChatGPT">
   <a:themeElements>
     <a:clrScheme name="ChatGPT">
@@ -1120,7 +1120,7 @@
 </p:notes>
 </file>
 
-<file path=ppt/slideLayouts/slideLayout2.xml><?xml version="1.0" encoding="utf-8"?>
+<file path=ppt/slideLayouts/slideLayout1.xml><?xml version="1.0" encoding="utf-8"?>
 <p:sldLayout xmlns:p="http://schemas.openxmlformats.org/presentationml/2006/main" type="title">
   <p:cSld name="Title Slide">
     <p:spTree>
@@ -1158,7 +1158,7 @@
   </p:cSld>
   <p:clrMap bg1="lt1" tx1="dk1" bg2="lt2" tx2="dk2" accent1="accent1" accent2="accent2" accent3="accent3" accent4="accent4" accent5="accent5" accent6="accent6" hlink="hlink" folHlink="folHlink"/>
   <p:sldLayoutIdLst>
-    <p:sldLayoutId xmlns:r="http://schemas.openxmlformats.org/officeDocument/2006/relationships" id="2147483649" r:id="R1aaaeee479644c93"/>
+    <p:sldLayoutId xmlns:r="http://schemas.openxmlformats.org/officeDocument/2006/relationships" id="2147483649" r:id="R56e8594a07974156"/>
   </p:sldLayoutIdLst>
   <p:txStyles>
     <p:titleStyle>
@@ -1438,6 +1438,205 @@
     </p:otherStyle>
   </p:txStyles>
 </p:sldMaster>
+</file>
+
+<file path=ppt/slideMasters/theme/theme2.xml><?xml version="1.0" encoding="utf-8"?>
+<a:theme xmlns:a="http://schemas.openxmlformats.org/drawingml/2006/main" name="ChatGPT">
+  <a:themeElements>
+    <a:clrScheme name="ChatGPT">
+      <a:dk1>
+        <a:srgbClr val="000000"/>
+      </a:dk1>
+      <a:lt1>
+        <a:srgbClr val="FFFFFF"/>
+      </a:lt1>
+      <a:dk2>
+        <a:srgbClr val="0E2841"/>
+      </a:dk2>
+      <a:lt2>
+        <a:srgbClr val="E8E8E8"/>
+      </a:lt2>
+      <a:accent1>
+        <a:srgbClr val="156082"/>
+      </a:accent1>
+      <a:accent2>
+        <a:srgbClr val="E97132"/>
+      </a:accent2>
+      <a:accent3>
+        <a:srgbClr val="196B24"/>
+      </a:accent3>
+      <a:accent4>
+        <a:srgbClr val="0F9ED5"/>
+      </a:accent4>
+      <a:accent5>
+        <a:srgbClr val="A02B93"/>
+      </a:accent5>
+      <a:accent6>
+        <a:srgbClr val="4EA72E"/>
+      </a:accent6>
+      <a:hlink>
+        <a:srgbClr val="467886"/>
+      </a:hlink>
+      <a:folHlink>
+        <a:srgbClr val="96607D"/>
+      </a:folHlink>
+    </a:clrScheme>
+    <a:fontScheme name="Office">
+      <a:majorFont>
+        <a:latin typeface="Calibri Light"/>
+        <a:ea typeface="Calibri Light"/>
+        <a:cs typeface="Calibri Light"/>
+      </a:majorFont>
+      <a:minorFont>
+        <a:latin typeface="Calibri"/>
+        <a:ea typeface="Calibri"/>
+        <a:cs typeface="Calibri"/>
+      </a:minorFont>
+    </a:fontScheme>
+    <a:fmtScheme name="ChatGPT">
+      <a:fillStyleLst>
+        <a:solidFill>
+          <a:schemeClr val="phClr"/>
+        </a:solidFill>
+        <a:solidFill>
+          <a:schemeClr val="dk1"/>
+        </a:solidFill>
+        <a:solidFill>
+          <a:schemeClr val="accent1"/>
+        </a:solidFill>
+      </a:fillStyleLst>
+      <a:lnStyleLst>
+        <a:ln w="12700">
+          <a:solidFill>
+            <a:schemeClr val="phClr"/>
+          </a:solidFill>
+          <a:prstDash val="solid"/>
+        </a:ln>
+        <a:ln w="19050">
+          <a:solidFill>
+            <a:schemeClr val="phClr"/>
+          </a:solidFill>
+          <a:prstDash val="solid"/>
+        </a:ln>
+        <a:ln w="25400">
+          <a:solidFill>
+            <a:schemeClr val="phClr"/>
+          </a:solidFill>
+          <a:prstDash val="solid"/>
+        </a:ln>
+      </a:lnStyleLst>
+      <a:effectStyleLst>
+        <a:effectStyle>
+          <a:effectLst/>
+        </a:effectStyle>
+        <a:effectStyle>
+          <a:effectLst/>
+        </a:effectStyle>
+        <a:effectStyle>
+          <a:effectLst>
+            <a:outerShdw blurRad="57150" dist="19050" dir="5400000">
+              <a:srgbClr val="000000">
+                <a:alpha val="16000"/>
+              </a:srgbClr>
+            </a:outerShdw>
+          </a:effectLst>
+        </a:effectStyle>
+        <a:effectStyle>
+          <a:effectLst>
+            <a:outerShdw blurRad="19050" dist="9525" dir="5400000">
+              <a:srgbClr val="000000">
+                <a:alpha val="6000"/>
+              </a:srgbClr>
+            </a:outerShdw>
+          </a:effectLst>
+        </a:effectStyle>
+        <a:effectStyle>
+          <a:effectLst>
+            <a:outerShdw blurRad="28575" dist="9525" dir="5400000">
+              <a:srgbClr val="000000">
+                <a:alpha val="8000"/>
+              </a:srgbClr>
+            </a:outerShdw>
+          </a:effectLst>
+        </a:effectStyle>
+        <a:effectStyle>
+          <a:effectLst>
+            <a:outerShdw blurRad="57150" dist="19050" dir="5400000">
+              <a:srgbClr val="000000">
+                <a:alpha val="10000"/>
+              </a:srgbClr>
+            </a:outerShdw>
+          </a:effectLst>
+        </a:effectStyle>
+        <a:effectStyle>
+          <a:effectLst>
+            <a:outerShdw blurRad="114300" dist="38100" dir="5400000">
+              <a:srgbClr val="000000">
+                <a:alpha val="12000"/>
+              </a:srgbClr>
+            </a:outerShdw>
+          </a:effectLst>
+        </a:effectStyle>
+        <a:effectStyle>
+          <a:effectLst>
+            <a:outerShdw blurRad="171450" dist="57150" dir="5400000">
+              <a:srgbClr val="000000">
+                <a:alpha val="16000"/>
+              </a:srgbClr>
+            </a:outerShdw>
+          </a:effectLst>
+        </a:effectStyle>
+        <a:effectStyle>
+          <a:effectLst>
+            <a:outerShdw blurRad="266700" dist="95250" dir="5400000">
+              <a:srgbClr val="000000">
+                <a:alpha val="24000"/>
+              </a:srgbClr>
+            </a:outerShdw>
+          </a:effectLst>
+        </a:effectStyle>
+      </a:effectStyleLst>
+      <a:bgFillStyleLst>
+        <a:solidFill>
+          <a:schemeClr val="phClr"/>
+        </a:solidFill>
+        <a:solidFill>
+          <a:schemeClr val="phClr">
+            <a:tint val="95000"/>
+            <a:satMod val="170000"/>
+          </a:schemeClr>
+        </a:solidFill>
+        <a:gradFill>
+          <a:gsLst>
+            <a:gs pos="0">
+              <a:schemeClr val="phClr">
+                <a:tint val="93000"/>
+                <a:shade val="98000"/>
+                <a:lumMod val="102000"/>
+                <a:satMod val="150000"/>
+              </a:schemeClr>
+            </a:gs>
+            <a:gs pos="50000">
+              <a:schemeClr val="phClr">
+                <a:tint val="98000"/>
+                <a:shade val="90000"/>
+                <a:lumMod val="103000"/>
+                <a:satMod val="130000"/>
+              </a:schemeClr>
+            </a:gs>
+            <a:gs pos="100000">
+              <a:schemeClr val="phClr">
+                <a:shade val="63000"/>
+                <a:satMod val="120000"/>
+              </a:schemeClr>
+            </a:gs>
+          </a:gsLst>
+          <a:lin ang="5400000" scaled="0"/>
+        </a:gradFill>
+      </a:bgFillStyleLst>
+    </a:fmtScheme>
+  </a:themeElements>
+</a:theme>
 </file>
 
 <file path=ppt/slides/slide1.xml><?xml version="1.0" encoding="utf-8"?>
@@ -1605,6 +1804,7 @@
           <a:lstStyle xmlns:a="http://schemas.openxmlformats.org/drawingml/2006/main"/>
           <a:p xmlns:a="http://schemas.openxmlformats.org/drawingml/2006/main">
             <a:pPr algn="l">
+              <a:buNone/>
               <a:defRPr sz="2550" b="1">
                 <a:solidFill>
                   <a:srgbClr val="FFFFFF"/>
@@ -1669,6 +1869,7 @@
           <a:lstStyle xmlns:a="http://schemas.openxmlformats.org/drawingml/2006/main"/>
           <a:p xmlns:a="http://schemas.openxmlformats.org/drawingml/2006/main">
             <a:pPr algn="l">
+              <a:buNone/>
               <a:defRPr sz="1800" b="0">
                 <a:solidFill>
                   <a:srgbClr val="FFE9B0"/>
@@ -1733,6 +1934,7 @@
           <a:lstStyle xmlns:a="http://schemas.openxmlformats.org/drawingml/2006/main"/>
           <a:p xmlns:a="http://schemas.openxmlformats.org/drawingml/2006/main">
             <a:pPr algn="l">
+              <a:buNone/>
               <a:defRPr sz="1200" b="0">
                 <a:solidFill>
                   <a:srgbClr val="FFFFFF"/>
@@ -1756,6 +1958,7 @@
           </a:p>
           <a:p xmlns:a="http://schemas.openxmlformats.org/drawingml/2006/main">
             <a:pPr algn="l">
+              <a:buNone/>
               <a:defRPr sz="1200" b="0">
                 <a:solidFill>
                   <a:srgbClr val="FFFFFF"/>
@@ -1820,6 +2023,7 @@
           <a:lstStyle xmlns:a="http://schemas.openxmlformats.org/drawingml/2006/main"/>
           <a:p xmlns:a="http://schemas.openxmlformats.org/drawingml/2006/main">
             <a:pPr algn="l">
+              <a:buNone/>
               <a:defRPr sz="3150" b="1">
                 <a:solidFill>
                   <a:srgbClr val="1E2330"/>
@@ -1884,6 +2088,7 @@
           <a:lstStyle xmlns:a="http://schemas.openxmlformats.org/drawingml/2006/main"/>
           <a:p xmlns:a="http://schemas.openxmlformats.org/drawingml/2006/main">
             <a:pPr algn="l">
+              <a:buNone/>
               <a:defRPr sz="1875" b="0">
                 <a:solidFill>
                   <a:srgbClr val="5B6270"/>
@@ -1981,6 +2186,7 @@
           <a:lstStyle xmlns:a="http://schemas.openxmlformats.org/drawingml/2006/main"/>
           <a:p xmlns:a="http://schemas.openxmlformats.org/drawingml/2006/main">
             <a:pPr algn="l">
+              <a:buNone/>
               <a:defRPr sz="1275" b="1">
                 <a:solidFill>
                   <a:srgbClr val="7A0C2E"/>
@@ -2045,6 +2251,7 @@
           <a:lstStyle xmlns:a="http://schemas.openxmlformats.org/drawingml/2006/main"/>
           <a:p xmlns:a="http://schemas.openxmlformats.org/drawingml/2006/main">
             <a:pPr algn="l">
+              <a:buNone/>
               <a:defRPr sz="1275" b="0">
                 <a:solidFill>
                   <a:srgbClr val="1E2330"/>
@@ -2142,6 +2349,7 @@
           <a:lstStyle xmlns:a="http://schemas.openxmlformats.org/drawingml/2006/main"/>
           <a:p xmlns:a="http://schemas.openxmlformats.org/drawingml/2006/main">
             <a:pPr algn="l">
+              <a:buNone/>
               <a:defRPr sz="1275" b="1">
                 <a:solidFill>
                   <a:srgbClr val="7A0C2E"/>
@@ -2206,6 +2414,7 @@
           <a:lstStyle xmlns:a="http://schemas.openxmlformats.org/drawingml/2006/main"/>
           <a:p xmlns:a="http://schemas.openxmlformats.org/drawingml/2006/main">
             <a:pPr algn="l">
+              <a:buNone/>
               <a:defRPr sz="1275" b="0">
                 <a:solidFill>
                   <a:srgbClr val="1E2330"/>
@@ -2303,6 +2512,7 @@
           <a:lstStyle xmlns:a="http://schemas.openxmlformats.org/drawingml/2006/main"/>
           <a:p xmlns:a="http://schemas.openxmlformats.org/drawingml/2006/main">
             <a:pPr algn="l">
+              <a:buNone/>
               <a:defRPr sz="1275" b="1">
                 <a:solidFill>
                   <a:srgbClr val="7A0C2E"/>
@@ -2367,6 +2577,7 @@
           <a:lstStyle xmlns:a="http://schemas.openxmlformats.org/drawingml/2006/main"/>
           <a:p xmlns:a="http://schemas.openxmlformats.org/drawingml/2006/main">
             <a:pPr algn="l">
+              <a:buNone/>
               <a:defRPr sz="1275" b="0">
                 <a:solidFill>
                   <a:srgbClr val="1E2330"/>
@@ -2530,6 +2741,7 @@
           <a:lstStyle xmlns:a="http://schemas.openxmlformats.org/drawingml/2006/main"/>
           <a:p xmlns:a="http://schemas.openxmlformats.org/drawingml/2006/main">
             <a:pPr algn="l">
+              <a:buNone/>
               <a:defRPr sz="2100" b="1">
                 <a:solidFill>
                   <a:srgbClr val="FFFFFF"/>
@@ -2594,6 +2806,7 @@
           <a:lstStyle xmlns:a="http://schemas.openxmlformats.org/drawingml/2006/main"/>
           <a:p xmlns:a="http://schemas.openxmlformats.org/drawingml/2006/main">
             <a:pPr algn="r">
+              <a:buNone/>
               <a:defRPr sz="900" b="1">
                 <a:solidFill>
                   <a:srgbClr val="FFE9B0"/>
@@ -2726,6 +2939,7 @@
           <a:lstStyle xmlns:a="http://schemas.openxmlformats.org/drawingml/2006/main"/>
           <a:p xmlns:a="http://schemas.openxmlformats.org/drawingml/2006/main">
             <a:pPr algn="l">
+              <a:buNone/>
               <a:defRPr sz="1425" b="1">
                 <a:solidFill>
                   <a:srgbClr val="7A0C2E"/>
@@ -2790,6 +3004,7 @@
           <a:lstStyle xmlns:a="http://schemas.openxmlformats.org/drawingml/2006/main"/>
           <a:p xmlns:a="http://schemas.openxmlformats.org/drawingml/2006/main">
             <a:pPr algn="l">
+              <a:buNone/>
               <a:defRPr sz="1125" b="0">
                 <a:solidFill>
                   <a:srgbClr val="1E2330"/>
@@ -2813,6 +3028,7 @@
           </a:p>
           <a:p xmlns:a="http://schemas.openxmlformats.org/drawingml/2006/main">
             <a:pPr algn="l">
+              <a:buNone/>
               <a:defRPr sz="1125" b="0">
                 <a:solidFill>
                   <a:srgbClr val="1E2330"/>
@@ -2836,6 +3052,7 @@
           </a:p>
           <a:p xmlns:a="http://schemas.openxmlformats.org/drawingml/2006/main">
             <a:pPr algn="l">
+              <a:buNone/>
               <a:defRPr sz="1125" b="0">
                 <a:solidFill>
                   <a:srgbClr val="1E2330"/>
@@ -2859,6 +3076,7 @@
           </a:p>
           <a:p xmlns:a="http://schemas.openxmlformats.org/drawingml/2006/main">
             <a:pPr algn="l">
+              <a:buNone/>
               <a:defRPr sz="1125" b="0">
                 <a:solidFill>
                   <a:srgbClr val="1E2330"/>
@@ -2882,6 +3100,7 @@
           </a:p>
           <a:p xmlns:a="http://schemas.openxmlformats.org/drawingml/2006/main">
             <a:pPr algn="l">
+              <a:buNone/>
               <a:defRPr sz="1125" b="0">
                 <a:solidFill>
                   <a:srgbClr val="1E2330"/>
@@ -3014,6 +3233,7 @@
           <a:lstStyle xmlns:a="http://schemas.openxmlformats.org/drawingml/2006/main"/>
           <a:p xmlns:a="http://schemas.openxmlformats.org/drawingml/2006/main">
             <a:pPr algn="l">
+              <a:buNone/>
               <a:defRPr sz="1425" b="1">
                 <a:solidFill>
                   <a:srgbClr val="138A52"/>
@@ -3078,6 +3298,7 @@
           <a:lstStyle xmlns:a="http://schemas.openxmlformats.org/drawingml/2006/main"/>
           <a:p xmlns:a="http://schemas.openxmlformats.org/drawingml/2006/main">
             <a:pPr algn="l">
+              <a:buNone/>
               <a:defRPr sz="1125" b="0">
                 <a:solidFill>
                   <a:srgbClr val="1E2330"/>
@@ -3101,6 +3322,7 @@
           </a:p>
           <a:p xmlns:a="http://schemas.openxmlformats.org/drawingml/2006/main">
             <a:pPr algn="l">
+              <a:buNone/>
               <a:defRPr sz="1125" b="0">
                 <a:solidFill>
                   <a:srgbClr val="1E2330"/>
@@ -3124,6 +3346,7 @@
           </a:p>
           <a:p xmlns:a="http://schemas.openxmlformats.org/drawingml/2006/main">
             <a:pPr algn="l">
+              <a:buNone/>
               <a:defRPr sz="1125" b="0">
                 <a:solidFill>
                   <a:srgbClr val="1E2330"/>
@@ -3147,6 +3370,7 @@
           </a:p>
           <a:p xmlns:a="http://schemas.openxmlformats.org/drawingml/2006/main">
             <a:pPr algn="l">
+              <a:buNone/>
               <a:defRPr sz="1125" b="0">
                 <a:solidFill>
                   <a:srgbClr val="1E2330"/>
@@ -3170,6 +3394,7 @@
           </a:p>
           <a:p xmlns:a="http://schemas.openxmlformats.org/drawingml/2006/main">
             <a:pPr algn="l">
+              <a:buNone/>
               <a:defRPr sz="1125" b="0">
                 <a:solidFill>
                   <a:srgbClr val="1E2330"/>
@@ -3193,6 +3418,7 @@
           </a:p>
           <a:p xmlns:a="http://schemas.openxmlformats.org/drawingml/2006/main">
             <a:pPr algn="l">
+              <a:buNone/>
               <a:defRPr sz="1125" b="0">
                 <a:solidFill>
                   <a:srgbClr val="1E2330"/>
@@ -3257,6 +3483,7 @@
           <a:lstStyle xmlns:a="http://schemas.openxmlformats.org/drawingml/2006/main"/>
           <a:p xmlns:a="http://schemas.openxmlformats.org/drawingml/2006/main">
             <a:pPr algn="ctr">
+              <a:buNone/>
               <a:defRPr sz="1800" b="1">
                 <a:solidFill>
                   <a:srgbClr val="7A0C2E"/>
@@ -3420,6 +3647,7 @@
           <a:lstStyle xmlns:a="http://schemas.openxmlformats.org/drawingml/2006/main"/>
           <a:p xmlns:a="http://schemas.openxmlformats.org/drawingml/2006/main">
             <a:pPr algn="l">
+              <a:buNone/>
               <a:defRPr sz="2100" b="1">
                 <a:solidFill>
                   <a:srgbClr val="FFFFFF"/>
@@ -3484,6 +3712,7 @@
           <a:lstStyle xmlns:a="http://schemas.openxmlformats.org/drawingml/2006/main"/>
           <a:p xmlns:a="http://schemas.openxmlformats.org/drawingml/2006/main">
             <a:pPr algn="r">
+              <a:buNone/>
               <a:defRPr sz="900" b="1">
                 <a:solidFill>
                   <a:srgbClr val="FFE9B0"/>
@@ -3616,6 +3845,7 @@
           <a:lstStyle xmlns:a="http://schemas.openxmlformats.org/drawingml/2006/main"/>
           <a:p xmlns:a="http://schemas.openxmlformats.org/drawingml/2006/main">
             <a:pPr algn="l">
+              <a:buNone/>
               <a:defRPr sz="1425" b="1">
                 <a:solidFill>
                   <a:srgbClr val="7A0C2E"/>
@@ -3680,6 +3910,7 @@
           <a:lstStyle xmlns:a="http://schemas.openxmlformats.org/drawingml/2006/main"/>
           <a:p xmlns:a="http://schemas.openxmlformats.org/drawingml/2006/main">
             <a:pPr algn="l">
+              <a:buNone/>
               <a:defRPr sz="1125" b="0">
                 <a:solidFill>
                   <a:srgbClr val="1E2330"/>
@@ -3703,6 +3934,7 @@
           </a:p>
           <a:p xmlns:a="http://schemas.openxmlformats.org/drawingml/2006/main">
             <a:pPr algn="l">
+              <a:buNone/>
               <a:defRPr sz="1125" b="0">
                 <a:solidFill>
                   <a:srgbClr val="1E2330"/>
@@ -3726,6 +3958,7 @@
           </a:p>
           <a:p xmlns:a="http://schemas.openxmlformats.org/drawingml/2006/main">
             <a:pPr algn="l">
+              <a:buNone/>
               <a:defRPr sz="1125" b="0">
                 <a:solidFill>
                   <a:srgbClr val="1E2330"/>
@@ -3749,6 +3982,7 @@
           </a:p>
           <a:p xmlns:a="http://schemas.openxmlformats.org/drawingml/2006/main">
             <a:pPr algn="l">
+              <a:buNone/>
               <a:defRPr sz="1125" b="0">
                 <a:solidFill>
                   <a:srgbClr val="1E2330"/>
@@ -3881,6 +4115,7 @@
           <a:lstStyle xmlns:a="http://schemas.openxmlformats.org/drawingml/2006/main"/>
           <a:p xmlns:a="http://schemas.openxmlformats.org/drawingml/2006/main">
             <a:pPr algn="l">
+              <a:buNone/>
               <a:defRPr sz="1425" b="1">
                 <a:solidFill>
                   <a:srgbClr val="138A52"/>
@@ -3945,6 +4180,7 @@
           <a:lstStyle xmlns:a="http://schemas.openxmlformats.org/drawingml/2006/main"/>
           <a:p xmlns:a="http://schemas.openxmlformats.org/drawingml/2006/main">
             <a:pPr algn="l">
+              <a:buNone/>
               <a:defRPr sz="1125" b="0">
                 <a:solidFill>
                   <a:srgbClr val="1E2330"/>
@@ -3968,6 +4204,7 @@
           </a:p>
           <a:p xmlns:a="http://schemas.openxmlformats.org/drawingml/2006/main">
             <a:pPr algn="l">
+              <a:buNone/>
               <a:defRPr sz="1125" b="0">
                 <a:solidFill>
                   <a:srgbClr val="1E2330"/>
@@ -3991,6 +4228,7 @@
           </a:p>
           <a:p xmlns:a="http://schemas.openxmlformats.org/drawingml/2006/main">
             <a:pPr algn="l">
+              <a:buNone/>
               <a:defRPr sz="1125" b="0">
                 <a:solidFill>
                   <a:srgbClr val="1E2330"/>
@@ -4014,6 +4252,7 @@
           </a:p>
           <a:p xmlns:a="http://schemas.openxmlformats.org/drawingml/2006/main">
             <a:pPr algn="l">
+              <a:buNone/>
               <a:defRPr sz="1125" b="0">
                 <a:solidFill>
                   <a:srgbClr val="1E2330"/>
@@ -4037,6 +4276,7 @@
           </a:p>
           <a:p xmlns:a="http://schemas.openxmlformats.org/drawingml/2006/main">
             <a:pPr algn="l">
+              <a:buNone/>
               <a:defRPr sz="1125" b="0">
                 <a:solidFill>
                   <a:srgbClr val="1E2330"/>
@@ -4169,6 +4409,7 @@
           <a:lstStyle xmlns:a="http://schemas.openxmlformats.org/drawingml/2006/main"/>
           <a:p xmlns:a="http://schemas.openxmlformats.org/drawingml/2006/main">
             <a:pPr algn="l">
+              <a:buNone/>
               <a:defRPr sz="1425" b="1">
                 <a:solidFill>
                   <a:srgbClr val="F2A900"/>
@@ -4233,6 +4474,7 @@
           <a:lstStyle xmlns:a="http://schemas.openxmlformats.org/drawingml/2006/main"/>
           <a:p xmlns:a="http://schemas.openxmlformats.org/drawingml/2006/main">
             <a:pPr algn="l">
+              <a:buNone/>
               <a:defRPr sz="1125" b="0">
                 <a:solidFill>
                   <a:srgbClr val="1E2330"/>
@@ -4256,6 +4498,7 @@
           </a:p>
           <a:p xmlns:a="http://schemas.openxmlformats.org/drawingml/2006/main">
             <a:pPr algn="l">
+              <a:buNone/>
               <a:defRPr sz="1125" b="0">
                 <a:solidFill>
                   <a:srgbClr val="1E2330"/>
@@ -4279,6 +4522,7 @@
           </a:p>
           <a:p xmlns:a="http://schemas.openxmlformats.org/drawingml/2006/main">
             <a:pPr algn="l">
+              <a:buNone/>
               <a:defRPr sz="1125" b="0">
                 <a:solidFill>
                   <a:srgbClr val="1E2330"/>
@@ -4302,6 +4546,7 @@
           </a:p>
           <a:p xmlns:a="http://schemas.openxmlformats.org/drawingml/2006/main">
             <a:pPr algn="l">
+              <a:buNone/>
               <a:defRPr sz="1125" b="0">
                 <a:solidFill>
                   <a:srgbClr val="1E2330"/>
@@ -4366,6 +4611,7 @@
           <a:lstStyle xmlns:a="http://schemas.openxmlformats.org/drawingml/2006/main"/>
           <a:p xmlns:a="http://schemas.openxmlformats.org/drawingml/2006/main">
             <a:pPr algn="ctr">
+              <a:buNone/>
               <a:defRPr sz="2100" b="1">
                 <a:solidFill>
                   <a:srgbClr val="1E2330"/>
@@ -4529,6 +4775,7 @@
           <a:lstStyle xmlns:a="http://schemas.openxmlformats.org/drawingml/2006/main"/>
           <a:p xmlns:a="http://schemas.openxmlformats.org/drawingml/2006/main">
             <a:pPr algn="l">
+              <a:buNone/>
               <a:defRPr sz="2100" b="1">
                 <a:solidFill>
                   <a:srgbClr val="FFFFFF"/>
@@ -4593,6 +4840,7 @@
           <a:lstStyle xmlns:a="http://schemas.openxmlformats.org/drawingml/2006/main"/>
           <a:p xmlns:a="http://schemas.openxmlformats.org/drawingml/2006/main">
             <a:pPr algn="r">
+              <a:buNone/>
               <a:defRPr sz="900" b="1">
                 <a:solidFill>
                   <a:srgbClr val="FFE9B0"/>
@@ -4690,6 +4938,7 @@
           <a:lstStyle xmlns:a="http://schemas.openxmlformats.org/drawingml/2006/main"/>
           <a:p xmlns:a="http://schemas.openxmlformats.org/drawingml/2006/main">
             <a:pPr algn="l">
+              <a:buNone/>
               <a:defRPr sz="1350" b="1">
                 <a:solidFill>
                   <a:srgbClr val="138A52"/>
@@ -4754,6 +5003,7 @@
           <a:lstStyle xmlns:a="http://schemas.openxmlformats.org/drawingml/2006/main"/>
           <a:p xmlns:a="http://schemas.openxmlformats.org/drawingml/2006/main">
             <a:pPr algn="l">
+              <a:buNone/>
               <a:defRPr sz="1350" b="0">
                 <a:solidFill>
                   <a:srgbClr val="1E2330"/>
@@ -4851,6 +5101,7 @@
           <a:lstStyle xmlns:a="http://schemas.openxmlformats.org/drawingml/2006/main"/>
           <a:p xmlns:a="http://schemas.openxmlformats.org/drawingml/2006/main">
             <a:pPr algn="l">
+              <a:buNone/>
               <a:defRPr sz="1350" b="1">
                 <a:solidFill>
                   <a:srgbClr val="138A52"/>
@@ -4915,6 +5166,7 @@
           <a:lstStyle xmlns:a="http://schemas.openxmlformats.org/drawingml/2006/main"/>
           <a:p xmlns:a="http://schemas.openxmlformats.org/drawingml/2006/main">
             <a:pPr algn="l">
+              <a:buNone/>
               <a:defRPr sz="1350" b="0">
                 <a:solidFill>
                   <a:srgbClr val="1E2330"/>
@@ -5012,6 +5264,7 @@
           <a:lstStyle xmlns:a="http://schemas.openxmlformats.org/drawingml/2006/main"/>
           <a:p xmlns:a="http://schemas.openxmlformats.org/drawingml/2006/main">
             <a:pPr algn="l">
+              <a:buNone/>
               <a:defRPr sz="1350" b="1">
                 <a:solidFill>
                   <a:srgbClr val="F2A900"/>
@@ -5076,6 +5329,7 @@
           <a:lstStyle xmlns:a="http://schemas.openxmlformats.org/drawingml/2006/main"/>
           <a:p xmlns:a="http://schemas.openxmlformats.org/drawingml/2006/main">
             <a:pPr algn="l">
+              <a:buNone/>
               <a:defRPr sz="1350" b="0">
                 <a:solidFill>
                   <a:srgbClr val="1E2330"/>
@@ -5173,6 +5427,7 @@
           <a:lstStyle xmlns:a="http://schemas.openxmlformats.org/drawingml/2006/main"/>
           <a:p xmlns:a="http://schemas.openxmlformats.org/drawingml/2006/main">
             <a:pPr algn="l">
+              <a:buNone/>
               <a:defRPr sz="1350" b="1">
                 <a:solidFill>
                   <a:srgbClr val="F2A900"/>
@@ -5237,6 +5492,7 @@
           <a:lstStyle xmlns:a="http://schemas.openxmlformats.org/drawingml/2006/main"/>
           <a:p xmlns:a="http://schemas.openxmlformats.org/drawingml/2006/main">
             <a:pPr algn="l">
+              <a:buNone/>
               <a:defRPr sz="1350" b="0">
                 <a:solidFill>
                   <a:srgbClr val="1E2330"/>
@@ -5301,6 +5557,7 @@
           <a:lstStyle xmlns:a="http://schemas.openxmlformats.org/drawingml/2006/main"/>
           <a:p xmlns:a="http://schemas.openxmlformats.org/drawingml/2006/main">
             <a:pPr algn="l">
+              <a:buNone/>
               <a:defRPr sz="1500" b="1">
                 <a:solidFill>
                   <a:srgbClr val="7A0C2E"/>
@@ -5464,6 +5721,7 @@
           <a:lstStyle xmlns:a="http://schemas.openxmlformats.org/drawingml/2006/main"/>
           <a:p xmlns:a="http://schemas.openxmlformats.org/drawingml/2006/main">
             <a:pPr algn="l">
+              <a:buNone/>
               <a:defRPr sz="2100" b="1">
                 <a:solidFill>
                   <a:srgbClr val="FFFFFF"/>
@@ -5528,6 +5786,7 @@
           <a:lstStyle xmlns:a="http://schemas.openxmlformats.org/drawingml/2006/main"/>
           <a:p xmlns:a="http://schemas.openxmlformats.org/drawingml/2006/main">
             <a:pPr algn="r">
+              <a:buNone/>
               <a:defRPr sz="900" b="1">
                 <a:solidFill>
                   <a:srgbClr val="FFE9B0"/>
@@ -5553,14 +5812,14 @@
       </p:sp>
       <p:pic>
         <p:nvPicPr>
-          <p:cNvPr id="5" name=""/>
+          <p:cNvPr id="20" name=""/>
           <p:cNvPicPr>
             <a:picLocks xmlns:a="http://schemas.openxmlformats.org/drawingml/2006/main" noChangeAspect="1"/>
           </p:cNvPicPr>
           <p:nvPr/>
         </p:nvPicPr>
         <p:blipFill>
-          <a:blip xmlns:r="http://schemas.openxmlformats.org/officeDocument/2006/relationships" xmlns:a="http://schemas.openxmlformats.org/drawingml/2006/main" r:embed="Rb091724486c34d88"/>
+          <a:blip xmlns:r="http://schemas.openxmlformats.org/officeDocument/2006/relationships" xmlns:a="http://schemas.openxmlformats.org/drawingml/2006/main" r:embed="R4a220a9a4828407e"/>
           <a:stretch xmlns:a="http://schemas.openxmlformats.org/drawingml/2006/main"/>
         </p:blipFill>
         <p:spPr>
@@ -5614,6 +5873,7 @@
           <a:lstStyle xmlns:a="http://schemas.openxmlformats.org/drawingml/2006/main"/>
           <a:p xmlns:a="http://schemas.openxmlformats.org/drawingml/2006/main">
             <a:pPr algn="ctr">
+              <a:buNone/>
               <a:defRPr sz="825" b="0">
                 <a:solidFill>
                   <a:srgbClr val="5B6270"/>
@@ -5746,6 +6006,7 @@
           <a:lstStyle xmlns:a="http://schemas.openxmlformats.org/drawingml/2006/main"/>
           <a:p xmlns:a="http://schemas.openxmlformats.org/drawingml/2006/main">
             <a:pPr algn="l">
+              <a:buNone/>
               <a:defRPr sz="1425" b="1">
                 <a:solidFill>
                   <a:srgbClr val="7A0C2E"/>
@@ -5810,6 +6071,7 @@
           <a:lstStyle xmlns:a="http://schemas.openxmlformats.org/drawingml/2006/main"/>
           <a:p xmlns:a="http://schemas.openxmlformats.org/drawingml/2006/main">
             <a:pPr algn="l">
+              <a:buNone/>
               <a:defRPr sz="1125" b="0">
                 <a:solidFill>
                   <a:srgbClr val="1E2330"/>
@@ -5833,6 +6095,7 @@
           </a:p>
           <a:p xmlns:a="http://schemas.openxmlformats.org/drawingml/2006/main">
             <a:pPr algn="l">
+              <a:buNone/>
               <a:defRPr sz="1125" b="0">
                 <a:solidFill>
                   <a:srgbClr val="1E2330"/>
@@ -5856,6 +6119,7 @@
           </a:p>
           <a:p xmlns:a="http://schemas.openxmlformats.org/drawingml/2006/main">
             <a:pPr algn="l">
+              <a:buNone/>
               <a:defRPr sz="1125" b="0">
                 <a:solidFill>
                   <a:srgbClr val="1E2330"/>
@@ -5988,6 +6252,7 @@
           <a:lstStyle xmlns:a="http://schemas.openxmlformats.org/drawingml/2006/main"/>
           <a:p xmlns:a="http://schemas.openxmlformats.org/drawingml/2006/main">
             <a:pPr algn="l">
+              <a:buNone/>
               <a:defRPr sz="1425" b="1">
                 <a:solidFill>
                   <a:srgbClr val="F2A900"/>
@@ -6052,6 +6317,7 @@
           <a:lstStyle xmlns:a="http://schemas.openxmlformats.org/drawingml/2006/main"/>
           <a:p xmlns:a="http://schemas.openxmlformats.org/drawingml/2006/main">
             <a:pPr algn="l">
+              <a:buNone/>
               <a:defRPr sz="1125" b="0">
                 <a:solidFill>
                   <a:srgbClr val="1E2330"/>
@@ -6075,6 +6341,7 @@
           </a:p>
           <a:p xmlns:a="http://schemas.openxmlformats.org/drawingml/2006/main">
             <a:pPr algn="l">
+              <a:buNone/>
               <a:defRPr sz="1125" b="0">
                 <a:solidFill>
                   <a:srgbClr val="1E2330"/>
@@ -6098,6 +6365,7 @@
           </a:p>
           <a:p xmlns:a="http://schemas.openxmlformats.org/drawingml/2006/main">
             <a:pPr algn="l">
+              <a:buNone/>
               <a:defRPr sz="1125" b="0">
                 <a:solidFill>
                   <a:srgbClr val="1E2330"/>
@@ -6121,6 +6389,7 @@
           </a:p>
           <a:p xmlns:a="http://schemas.openxmlformats.org/drawingml/2006/main">
             <a:pPr algn="l">
+              <a:buNone/>
               <a:defRPr sz="1125" b="0">
                 <a:solidFill>
                   <a:srgbClr val="1E2330"/>
@@ -6284,6 +6553,7 @@
           <a:lstStyle xmlns:a="http://schemas.openxmlformats.org/drawingml/2006/main"/>
           <a:p xmlns:a="http://schemas.openxmlformats.org/drawingml/2006/main">
             <a:pPr algn="l">
+              <a:buNone/>
               <a:defRPr sz="2100" b="1">
                 <a:solidFill>
                   <a:srgbClr val="FFFFFF"/>
@@ -6348,6 +6618,7 @@
           <a:lstStyle xmlns:a="http://schemas.openxmlformats.org/drawingml/2006/main"/>
           <a:p xmlns:a="http://schemas.openxmlformats.org/drawingml/2006/main">
             <a:pPr algn="r">
+              <a:buNone/>
               <a:defRPr sz="900" b="1">
                 <a:solidFill>
                   <a:srgbClr val="FFE9B0"/>
@@ -6373,14 +6644,14 @@
       </p:sp>
       <p:pic>
         <p:nvPicPr>
-          <p:cNvPr id="5" name=""/>
+          <p:cNvPr id="19" name=""/>
           <p:cNvPicPr>
             <a:picLocks xmlns:a="http://schemas.openxmlformats.org/drawingml/2006/main" noChangeAspect="1"/>
           </p:cNvPicPr>
           <p:nvPr/>
         </p:nvPicPr>
         <p:blipFill>
-          <a:blip xmlns:r="http://schemas.openxmlformats.org/officeDocument/2006/relationships" xmlns:a="http://schemas.openxmlformats.org/drawingml/2006/main" r:embed="R956ae3663c394e86"/>
+          <a:blip xmlns:r="http://schemas.openxmlformats.org/officeDocument/2006/relationships" xmlns:a="http://schemas.openxmlformats.org/drawingml/2006/main" r:embed="Ra78c4fb1be784e9e"/>
           <a:stretch xmlns:a="http://schemas.openxmlformats.org/drawingml/2006/main"/>
         </p:blipFill>
         <p:spPr>
@@ -6434,6 +6705,7 @@
           <a:lstStyle xmlns:a="http://schemas.openxmlformats.org/drawingml/2006/main"/>
           <a:p xmlns:a="http://schemas.openxmlformats.org/drawingml/2006/main">
             <a:pPr algn="ctr">
+              <a:buNone/>
               <a:defRPr sz="825" b="0">
                 <a:solidFill>
                   <a:srgbClr val="5B6270"/>
@@ -6459,14 +6731,14 @@
       </p:sp>
       <p:pic>
         <p:nvPicPr>
-          <p:cNvPr id="7" name=""/>
+          <p:cNvPr id="21" name=""/>
           <p:cNvPicPr>
             <a:picLocks xmlns:a="http://schemas.openxmlformats.org/drawingml/2006/main" noChangeAspect="1"/>
           </p:cNvPicPr>
           <p:nvPr/>
         </p:nvPicPr>
         <p:blipFill>
-          <a:blip xmlns:r="http://schemas.openxmlformats.org/officeDocument/2006/relationships" xmlns:a="http://schemas.openxmlformats.org/drawingml/2006/main" r:embed="R71a0afd32bc94276"/>
+          <a:blip xmlns:r="http://schemas.openxmlformats.org/officeDocument/2006/relationships" xmlns:a="http://schemas.openxmlformats.org/drawingml/2006/main" r:embed="Rb66c1e834bc746d1"/>
           <a:stretch xmlns:a="http://schemas.openxmlformats.org/drawingml/2006/main"/>
         </p:blipFill>
         <p:spPr>
@@ -6520,6 +6792,7 @@
           <a:lstStyle xmlns:a="http://schemas.openxmlformats.org/drawingml/2006/main"/>
           <a:p xmlns:a="http://schemas.openxmlformats.org/drawingml/2006/main">
             <a:pPr algn="ctr">
+              <a:buNone/>
               <a:defRPr sz="825" b="0">
                 <a:solidFill>
                   <a:srgbClr val="5B6270"/>
@@ -6545,14 +6818,14 @@
       </p:sp>
       <p:pic>
         <p:nvPicPr>
-          <p:cNvPr id="9" name=""/>
+          <p:cNvPr id="23" name=""/>
           <p:cNvPicPr>
             <a:picLocks xmlns:a="http://schemas.openxmlformats.org/drawingml/2006/main" noChangeAspect="1"/>
           </p:cNvPicPr>
           <p:nvPr/>
         </p:nvPicPr>
         <p:blipFill>
-          <a:blip xmlns:r="http://schemas.openxmlformats.org/officeDocument/2006/relationships" xmlns:a="http://schemas.openxmlformats.org/drawingml/2006/main" r:embed="R82019620499c4c1b"/>
+          <a:blip xmlns:r="http://schemas.openxmlformats.org/officeDocument/2006/relationships" xmlns:a="http://schemas.openxmlformats.org/drawingml/2006/main" r:embed="R15ce73085a3a46c5"/>
           <a:stretch xmlns:a="http://schemas.openxmlformats.org/drawingml/2006/main"/>
         </p:blipFill>
         <p:spPr>
@@ -6606,6 +6879,7 @@
           <a:lstStyle xmlns:a="http://schemas.openxmlformats.org/drawingml/2006/main"/>
           <a:p xmlns:a="http://schemas.openxmlformats.org/drawingml/2006/main">
             <a:pPr algn="ctr">
+              <a:buNone/>
               <a:defRPr sz="825" b="0">
                 <a:solidFill>
                   <a:srgbClr val="5B6270"/>
@@ -6670,6 +6944,7 @@
           <a:lstStyle xmlns:a="http://schemas.openxmlformats.org/drawingml/2006/main"/>
           <a:p xmlns:a="http://schemas.openxmlformats.org/drawingml/2006/main">
             <a:pPr algn="ctr">
+              <a:buNone/>
               <a:defRPr sz="2025" b="1">
                 <a:solidFill>
                   <a:srgbClr val="1E2330"/>
@@ -6833,6 +7108,7 @@
           <a:lstStyle xmlns:a="http://schemas.openxmlformats.org/drawingml/2006/main"/>
           <a:p xmlns:a="http://schemas.openxmlformats.org/drawingml/2006/main">
             <a:pPr algn="l">
+              <a:buNone/>
               <a:defRPr sz="2100" b="1">
                 <a:solidFill>
                   <a:srgbClr val="FFFFFF"/>
@@ -6897,6 +7173,7 @@
           <a:lstStyle xmlns:a="http://schemas.openxmlformats.org/drawingml/2006/main"/>
           <a:p xmlns:a="http://schemas.openxmlformats.org/drawingml/2006/main">
             <a:pPr algn="r">
+              <a:buNone/>
               <a:defRPr sz="900" b="1">
                 <a:solidFill>
                   <a:srgbClr val="FFE9B0"/>
@@ -6922,14 +7199,14 @@
       </p:sp>
       <p:pic>
         <p:nvPicPr>
-          <p:cNvPr id="5" name=""/>
+          <p:cNvPr id="20" name=""/>
           <p:cNvPicPr>
             <a:picLocks xmlns:a="http://schemas.openxmlformats.org/drawingml/2006/main" noChangeAspect="1"/>
           </p:cNvPicPr>
           <p:nvPr/>
         </p:nvPicPr>
         <p:blipFill>
-          <a:blip xmlns:r="http://schemas.openxmlformats.org/officeDocument/2006/relationships" xmlns:a="http://schemas.openxmlformats.org/drawingml/2006/main" r:embed="R4837a75a89334c19"/>
+          <a:blip xmlns:r="http://schemas.openxmlformats.org/officeDocument/2006/relationships" xmlns:a="http://schemas.openxmlformats.org/drawingml/2006/main" r:embed="R2d233425b3534679"/>
           <a:stretch xmlns:a="http://schemas.openxmlformats.org/drawingml/2006/main"/>
         </p:blipFill>
         <p:spPr>
@@ -6983,6 +7260,7 @@
           <a:lstStyle xmlns:a="http://schemas.openxmlformats.org/drawingml/2006/main"/>
           <a:p xmlns:a="http://schemas.openxmlformats.org/drawingml/2006/main">
             <a:pPr algn="ctr">
+              <a:buNone/>
               <a:defRPr sz="825" b="0">
                 <a:solidFill>
                   <a:srgbClr val="5B6270"/>
@@ -7115,6 +7393,7 @@
           <a:lstStyle xmlns:a="http://schemas.openxmlformats.org/drawingml/2006/main"/>
           <a:p xmlns:a="http://schemas.openxmlformats.org/drawingml/2006/main">
             <a:pPr algn="l">
+              <a:buNone/>
               <a:defRPr sz="1425" b="1">
                 <a:solidFill>
                   <a:srgbClr val="7A0C2E"/>
@@ -7179,6 +7458,7 @@
           <a:lstStyle xmlns:a="http://schemas.openxmlformats.org/drawingml/2006/main"/>
           <a:p xmlns:a="http://schemas.openxmlformats.org/drawingml/2006/main">
             <a:pPr algn="l">
+              <a:buNone/>
               <a:defRPr sz="1125" b="0">
                 <a:solidFill>
                   <a:srgbClr val="1E2330"/>
@@ -7311,6 +7591,7 @@
           <a:lstStyle xmlns:a="http://schemas.openxmlformats.org/drawingml/2006/main"/>
           <a:p xmlns:a="http://schemas.openxmlformats.org/drawingml/2006/main">
             <a:pPr algn="l">
+              <a:buNone/>
               <a:defRPr sz="1425" b="1">
                 <a:solidFill>
                   <a:srgbClr val="F2A900"/>
@@ -7375,6 +7656,7 @@
           <a:lstStyle xmlns:a="http://schemas.openxmlformats.org/drawingml/2006/main"/>
           <a:p xmlns:a="http://schemas.openxmlformats.org/drawingml/2006/main">
             <a:pPr algn="l">
+              <a:buNone/>
               <a:defRPr sz="1125" b="0">
                 <a:solidFill>
                   <a:srgbClr val="1E2330"/>
@@ -7538,6 +7820,7 @@
           <a:lstStyle xmlns:a="http://schemas.openxmlformats.org/drawingml/2006/main"/>
           <a:p xmlns:a="http://schemas.openxmlformats.org/drawingml/2006/main">
             <a:pPr algn="l">
+              <a:buNone/>
               <a:defRPr sz="2100" b="1">
                 <a:solidFill>
                   <a:srgbClr val="FFFFFF"/>
@@ -7602,6 +7885,7 @@
           <a:lstStyle xmlns:a="http://schemas.openxmlformats.org/drawingml/2006/main"/>
           <a:p xmlns:a="http://schemas.openxmlformats.org/drawingml/2006/main">
             <a:pPr algn="r">
+              <a:buNone/>
               <a:defRPr sz="900" b="1">
                 <a:solidFill>
                   <a:srgbClr val="FFE9B0"/>
@@ -7627,14 +7911,14 @@
       </p:sp>
       <p:pic>
         <p:nvPicPr>
-          <p:cNvPr id="5" name=""/>
+          <p:cNvPr id="24" name=""/>
           <p:cNvPicPr>
             <a:picLocks xmlns:a="http://schemas.openxmlformats.org/drawingml/2006/main" noChangeAspect="1"/>
           </p:cNvPicPr>
           <p:nvPr/>
         </p:nvPicPr>
         <p:blipFill>
-          <a:blip xmlns:r="http://schemas.openxmlformats.org/officeDocument/2006/relationships" xmlns:a="http://schemas.openxmlformats.org/drawingml/2006/main" r:embed="R676cc97586704978"/>
+          <a:blip xmlns:r="http://schemas.openxmlformats.org/officeDocument/2006/relationships" xmlns:a="http://schemas.openxmlformats.org/drawingml/2006/main" r:embed="R860cbf048cca497b"/>
           <a:stretch xmlns:a="http://schemas.openxmlformats.org/drawingml/2006/main"/>
         </p:blipFill>
         <p:spPr>
@@ -7688,6 +7972,7 @@
           <a:lstStyle xmlns:a="http://schemas.openxmlformats.org/drawingml/2006/main"/>
           <a:p xmlns:a="http://schemas.openxmlformats.org/drawingml/2006/main">
             <a:pPr algn="ctr">
+              <a:buNone/>
               <a:defRPr sz="825" b="0">
                 <a:solidFill>
                   <a:srgbClr val="5B6270"/>
@@ -7820,6 +8105,7 @@
           <a:lstStyle xmlns:a="http://schemas.openxmlformats.org/drawingml/2006/main"/>
           <a:p xmlns:a="http://schemas.openxmlformats.org/drawingml/2006/main">
             <a:pPr algn="l">
+              <a:buNone/>
               <a:defRPr sz="1425" b="1">
                 <a:solidFill>
                   <a:srgbClr val="138A52"/>
@@ -7884,6 +8170,7 @@
           <a:lstStyle xmlns:a="http://schemas.openxmlformats.org/drawingml/2006/main"/>
           <a:p xmlns:a="http://schemas.openxmlformats.org/drawingml/2006/main">
             <a:pPr algn="l">
+              <a:buNone/>
               <a:defRPr sz="1125" b="0">
                 <a:solidFill>
                   <a:srgbClr val="1E2330"/>
@@ -8016,6 +8303,7 @@
           <a:lstStyle xmlns:a="http://schemas.openxmlformats.org/drawingml/2006/main"/>
           <a:p xmlns:a="http://schemas.openxmlformats.org/drawingml/2006/main">
             <a:pPr algn="l">
+              <a:buNone/>
               <a:defRPr sz="1425" b="1">
                 <a:solidFill>
                   <a:srgbClr val="7A0C2E"/>
@@ -8080,6 +8368,7 @@
           <a:lstStyle xmlns:a="http://schemas.openxmlformats.org/drawingml/2006/main"/>
           <a:p xmlns:a="http://schemas.openxmlformats.org/drawingml/2006/main">
             <a:pPr algn="l">
+              <a:buNone/>
               <a:defRPr sz="1125" b="0">
                 <a:solidFill>
                   <a:srgbClr val="1E2330"/>
@@ -8212,6 +8501,7 @@
           <a:lstStyle xmlns:a="http://schemas.openxmlformats.org/drawingml/2006/main"/>
           <a:p xmlns:a="http://schemas.openxmlformats.org/drawingml/2006/main">
             <a:pPr algn="l">
+              <a:buNone/>
               <a:defRPr sz="1425" b="1">
                 <a:solidFill>
                   <a:srgbClr val="F2A900"/>
@@ -8276,6 +8566,7 @@
           <a:lstStyle xmlns:a="http://schemas.openxmlformats.org/drawingml/2006/main"/>
           <a:p xmlns:a="http://schemas.openxmlformats.org/drawingml/2006/main">
             <a:pPr algn="l">
+              <a:buNone/>
               <a:defRPr sz="1125" b="0">
                 <a:solidFill>
                   <a:srgbClr val="1E2330"/>
@@ -8439,6 +8730,7 @@
           <a:lstStyle xmlns:a="http://schemas.openxmlformats.org/drawingml/2006/main"/>
           <a:p xmlns:a="http://schemas.openxmlformats.org/drawingml/2006/main">
             <a:pPr algn="l">
+              <a:buNone/>
               <a:defRPr sz="2100" b="1">
                 <a:solidFill>
                   <a:srgbClr val="FFFFFF"/>
@@ -8503,6 +8795,7 @@
           <a:lstStyle xmlns:a="http://schemas.openxmlformats.org/drawingml/2006/main"/>
           <a:p xmlns:a="http://schemas.openxmlformats.org/drawingml/2006/main">
             <a:pPr algn="r">
+              <a:buNone/>
               <a:defRPr sz="900" b="1">
                 <a:solidFill>
                   <a:srgbClr val="FFE9B0"/>
@@ -8528,14 +8821,14 @@
       </p:sp>
       <p:pic>
         <p:nvPicPr>
-          <p:cNvPr id="5" name=""/>
+          <p:cNvPr id="16" name=""/>
           <p:cNvPicPr>
             <a:picLocks xmlns:a="http://schemas.openxmlformats.org/drawingml/2006/main" noChangeAspect="1"/>
           </p:cNvPicPr>
           <p:nvPr/>
         </p:nvPicPr>
         <p:blipFill>
-          <a:blip xmlns:r="http://schemas.openxmlformats.org/officeDocument/2006/relationships" xmlns:a="http://schemas.openxmlformats.org/drawingml/2006/main" r:embed="R45d36e4785754ba9"/>
+          <a:blip xmlns:r="http://schemas.openxmlformats.org/officeDocument/2006/relationships" xmlns:a="http://schemas.openxmlformats.org/drawingml/2006/main" r:embed="R8dc873ce7c014cb3"/>
           <a:stretch xmlns:a="http://schemas.openxmlformats.org/drawingml/2006/main"/>
         </p:blipFill>
         <p:spPr>
@@ -8589,6 +8882,7 @@
           <a:lstStyle xmlns:a="http://schemas.openxmlformats.org/drawingml/2006/main"/>
           <a:p xmlns:a="http://schemas.openxmlformats.org/drawingml/2006/main">
             <a:pPr algn="ctr">
+              <a:buNone/>
               <a:defRPr sz="825" b="0">
                 <a:solidFill>
                   <a:srgbClr val="5B6270"/>
@@ -8614,14 +8908,14 @@
       </p:sp>
       <p:pic>
         <p:nvPicPr>
-          <p:cNvPr id="7" name=""/>
+          <p:cNvPr id="18" name=""/>
           <p:cNvPicPr>
             <a:picLocks xmlns:a="http://schemas.openxmlformats.org/drawingml/2006/main" noChangeAspect="1"/>
           </p:cNvPicPr>
           <p:nvPr/>
         </p:nvPicPr>
         <p:blipFill>
-          <a:blip xmlns:r="http://schemas.openxmlformats.org/officeDocument/2006/relationships" xmlns:a="http://schemas.openxmlformats.org/drawingml/2006/main" r:embed="R398f8946f9384457"/>
+          <a:blip xmlns:r="http://schemas.openxmlformats.org/officeDocument/2006/relationships" xmlns:a="http://schemas.openxmlformats.org/drawingml/2006/main" r:embed="R87b8040db7ca4ed5"/>
           <a:stretch xmlns:a="http://schemas.openxmlformats.org/drawingml/2006/main"/>
         </p:blipFill>
         <p:spPr>
@@ -8675,6 +8969,7 @@
           <a:lstStyle xmlns:a="http://schemas.openxmlformats.org/drawingml/2006/main"/>
           <a:p xmlns:a="http://schemas.openxmlformats.org/drawingml/2006/main">
             <a:pPr algn="ctr">
+              <a:buNone/>
               <a:defRPr sz="825" b="0">
                 <a:solidFill>
                   <a:srgbClr val="5B6270"/>
@@ -8739,6 +9034,7 @@
           <a:lstStyle xmlns:a="http://schemas.openxmlformats.org/drawingml/2006/main"/>
           <a:p xmlns:a="http://schemas.openxmlformats.org/drawingml/2006/main">
             <a:pPr algn="ctr">
+              <a:buNone/>
               <a:defRPr sz="1800" b="1">
                 <a:solidFill>
                   <a:srgbClr val="1E2330"/>
@@ -8902,6 +9198,7 @@
           <a:lstStyle xmlns:a="http://schemas.openxmlformats.org/drawingml/2006/main"/>
           <a:p xmlns:a="http://schemas.openxmlformats.org/drawingml/2006/main">
             <a:pPr algn="l">
+              <a:buNone/>
               <a:defRPr sz="2100" b="1">
                 <a:solidFill>
                   <a:srgbClr val="FFFFFF"/>
@@ -8966,6 +9263,7 @@
           <a:lstStyle xmlns:a="http://schemas.openxmlformats.org/drawingml/2006/main"/>
           <a:p xmlns:a="http://schemas.openxmlformats.org/drawingml/2006/main">
             <a:pPr algn="r">
+              <a:buNone/>
               <a:defRPr sz="900" b="1">
                 <a:solidFill>
                   <a:srgbClr val="FFE9B0"/>
@@ -9063,6 +9361,7 @@
           <a:lstStyle xmlns:a="http://schemas.openxmlformats.org/drawingml/2006/main"/>
           <a:p xmlns:a="http://schemas.openxmlformats.org/drawingml/2006/main">
             <a:pPr algn="ctr">
+              <a:buNone/>
               <a:defRPr sz="1500" b="1">
                 <a:solidFill>
                   <a:srgbClr val="7A0C2E"/>
@@ -9127,6 +9426,7 @@
           <a:lstStyle xmlns:a="http://schemas.openxmlformats.org/drawingml/2006/main"/>
           <a:p xmlns:a="http://schemas.openxmlformats.org/drawingml/2006/main">
             <a:pPr algn="ctr">
+              <a:buNone/>
               <a:defRPr sz="1125" b="0">
                 <a:solidFill>
                   <a:srgbClr val="1E2330"/>
@@ -9191,6 +9491,7 @@
           <a:lstStyle xmlns:a="http://schemas.openxmlformats.org/drawingml/2006/main"/>
           <a:p xmlns:a="http://schemas.openxmlformats.org/drawingml/2006/main">
             <a:pPr algn="ctr">
+              <a:buNone/>
               <a:defRPr sz="2550" b="1">
                 <a:solidFill>
                   <a:srgbClr val="F2A900"/>
@@ -9288,6 +9589,7 @@
           <a:lstStyle xmlns:a="http://schemas.openxmlformats.org/drawingml/2006/main"/>
           <a:p xmlns:a="http://schemas.openxmlformats.org/drawingml/2006/main">
             <a:pPr algn="ctr">
+              <a:buNone/>
               <a:defRPr sz="1500" b="1">
                 <a:solidFill>
                   <a:srgbClr val="7A0C2E"/>
@@ -9352,6 +9654,7 @@
           <a:lstStyle xmlns:a="http://schemas.openxmlformats.org/drawingml/2006/main"/>
           <a:p xmlns:a="http://schemas.openxmlformats.org/drawingml/2006/main">
             <a:pPr algn="ctr">
+              <a:buNone/>
               <a:defRPr sz="1125" b="0">
                 <a:solidFill>
                   <a:srgbClr val="1E2330"/>
@@ -9416,6 +9719,7 @@
           <a:lstStyle xmlns:a="http://schemas.openxmlformats.org/drawingml/2006/main"/>
           <a:p xmlns:a="http://schemas.openxmlformats.org/drawingml/2006/main">
             <a:pPr algn="ctr">
+              <a:buNone/>
               <a:defRPr sz="2550" b="1">
                 <a:solidFill>
                   <a:srgbClr val="F2A900"/>
@@ -9513,6 +9817,7 @@
           <a:lstStyle xmlns:a="http://schemas.openxmlformats.org/drawingml/2006/main"/>
           <a:p xmlns:a="http://schemas.openxmlformats.org/drawingml/2006/main">
             <a:pPr algn="ctr">
+              <a:buNone/>
               <a:defRPr sz="1500" b="1">
                 <a:solidFill>
                   <a:srgbClr val="7A0C2E"/>
@@ -9577,6 +9882,7 @@
           <a:lstStyle xmlns:a="http://schemas.openxmlformats.org/drawingml/2006/main"/>
           <a:p xmlns:a="http://schemas.openxmlformats.org/drawingml/2006/main">
             <a:pPr algn="ctr">
+              <a:buNone/>
               <a:defRPr sz="1125" b="0">
                 <a:solidFill>
                   <a:srgbClr val="1E2330"/>
@@ -9641,6 +9947,7 @@
           <a:lstStyle xmlns:a="http://schemas.openxmlformats.org/drawingml/2006/main"/>
           <a:p xmlns:a="http://schemas.openxmlformats.org/drawingml/2006/main">
             <a:pPr algn="ctr">
+              <a:buNone/>
               <a:defRPr sz="2550" b="1">
                 <a:solidFill>
                   <a:srgbClr val="F2A900"/>
@@ -9738,6 +10045,7 @@
           <a:lstStyle xmlns:a="http://schemas.openxmlformats.org/drawingml/2006/main"/>
           <a:p xmlns:a="http://schemas.openxmlformats.org/drawingml/2006/main">
             <a:pPr algn="ctr">
+              <a:buNone/>
               <a:defRPr sz="1500" b="1">
                 <a:solidFill>
                   <a:srgbClr val="7A0C2E"/>
@@ -9802,6 +10110,7 @@
           <a:lstStyle xmlns:a="http://schemas.openxmlformats.org/drawingml/2006/main"/>
           <a:p xmlns:a="http://schemas.openxmlformats.org/drawingml/2006/main">
             <a:pPr algn="ctr">
+              <a:buNone/>
               <a:defRPr sz="1125" b="0">
                 <a:solidFill>
                   <a:srgbClr val="1E2330"/>
@@ -9866,6 +10175,7 @@
           <a:lstStyle xmlns:a="http://schemas.openxmlformats.org/drawingml/2006/main"/>
           <a:p xmlns:a="http://schemas.openxmlformats.org/drawingml/2006/main">
             <a:pPr algn="ctr">
+              <a:buNone/>
               <a:defRPr sz="2550" b="1">
                 <a:solidFill>
                   <a:srgbClr val="F2A900"/>
@@ -9963,6 +10273,7 @@
           <a:lstStyle xmlns:a="http://schemas.openxmlformats.org/drawingml/2006/main"/>
           <a:p xmlns:a="http://schemas.openxmlformats.org/drawingml/2006/main">
             <a:pPr algn="ctr">
+              <a:buNone/>
               <a:defRPr sz="1500" b="1">
                 <a:solidFill>
                   <a:srgbClr val="7A0C2E"/>
@@ -10027,6 +10338,7 @@
           <a:lstStyle xmlns:a="http://schemas.openxmlformats.org/drawingml/2006/main"/>
           <a:p xmlns:a="http://schemas.openxmlformats.org/drawingml/2006/main">
             <a:pPr algn="ctr">
+              <a:buNone/>
               <a:defRPr sz="1125" b="0">
                 <a:solidFill>
                   <a:srgbClr val="1E2330"/>
@@ -10091,6 +10403,7 @@
           <a:lstStyle xmlns:a="http://schemas.openxmlformats.org/drawingml/2006/main"/>
           <a:p xmlns:a="http://schemas.openxmlformats.org/drawingml/2006/main">
             <a:pPr algn="ctr">
+              <a:buNone/>
               <a:defRPr sz="2100" b="1">
                 <a:solidFill>
                   <a:srgbClr val="1E2330"/>

</xml_diff>

<commit_message>
Clean final deliverable wording
</commit_message>
<xml_diff>
--- a/TransitAI_UTM_Prototype_Demo.pptx
+++ b/TransitAI_UTM_Prototype_Demo.pptx
@@ -2596,7 +2596,7 @@
                 <a:ea typeface="Aptos"/>
                 <a:cs typeface="Aptos"/>
               </a:rPr>
-              <a:t>Public route labels + simulated timing boundary</a:t>
+              <a:t>Public route labels + prototype timing boundary</a:t>
             </a:r>
           </a:p>
         </p:txBody>
@@ -3095,7 +3095,7 @@
                 <a:ea typeface="Aptos"/>
                 <a:cs typeface="Aptos"/>
               </a:rPr>
-              <a:t>• Say timing/ETA are simulated POC data</a:t>
+              <a:t>• Say timing/ETA are configured estimates</a:t>
             </a:r>
           </a:p>
           <a:p xmlns:a="http://schemas.openxmlformats.org/drawingml/2006/main">
@@ -4630,7 +4630,7 @@
                 <a:ea typeface="Aptos"/>
                 <a:cs typeface="Aptos"/>
               </a:rPr>
-              <a:t>Main scoring risk reduced: the prototype now clearly labels what is public route data and what is simulated POC behavior. The demo-time control prevents night presentation from making every route look closed.</a:t>
+              <a:t>Main scoring risk reduced: the prototype now clearly labels what is public route data and what is configured estimate behavior. The demo-time control prevents night presentation from making every route look closed.</a:t>
             </a:r>
           </a:p>
         </p:txBody>
@@ -5446,7 +5446,7 @@
                 <a:ea typeface="Aptos"/>
                 <a:cs typeface="Aptos"/>
               </a:rPr>
-              <a:t>Simulated POC data</a:t>
+              <a:t>Configured estimate data</a:t>
             </a:r>
           </a:p>
         </p:txBody>
@@ -5576,7 +5576,7 @@
                 <a:ea typeface="Aptos"/>
                 <a:cs typeface="Aptos"/>
               </a:rPr>
-              <a:t>Presentation wording: “Route names and stop sequences follow public UTM/KDOJ listings where available. Timetable/ETA values are simulated because no live verified feed is connected to this 10% POC.”</a:t>
+              <a:t>Presentation wording: “Route names and stop sequences follow public UTM/KDOJ listings where available. Timetable/ETA values are configured estimates because no live verified feed is connected to this 10% POC.”</a:t>
             </a:r>
           </a:p>
         </p:txBody>
@@ -6898,7 +6898,7 @@
                 <a:ea typeface="Aptos"/>
                 <a:cs typeface="Aptos"/>
               </a:rPr>
-              <a:t>Arrival: simulated ETA</a:t>
+              <a:t>Arrival: estimated ETA</a:t>
             </a:r>
           </a:p>
         </p:txBody>
@@ -6963,7 +6963,7 @@
                 <a:ea typeface="Aptos"/>
                 <a:cs typeface="Aptos"/>
               </a:rPr>
-              <a:t>The marker sees the real problem being solved: students can ask natural questions instead of searching static notices. Each answer states the data source and simulation boundary.</a:t>
+              <a:t>The marker sees the real problem being solved: students can ask natural questions instead of searching static notices. Each answer states the data source and estimate boundary.</a:t>
             </a:r>
           </a:p>
         </p:txBody>

</xml_diff>